<commit_message>
agents slides: ag-02 lesson, Moda deck and PPTX; ag-01 table header contrast
Co-Authored-By: Claude Sonnet 5.5 <noreply@anthropic.com>
Claude-Session: https://claude.ai/code/session_01YGSUXJYSMCgd8FmP4BFSad
</commit_message>
<xml_diff>
--- a/ai-agents-for-beginners/vi/lessons/ag-01/ag-01.pptx
+++ b/ai-agents-for-beginners/vi/lessons/ag-01/ag-01.pptx
@@ -3525,7 +3525,7 @@
                       <a:noFill/>
                     </a:lnB>
                     <a:solidFill>
-                      <a:srgbClr val="7C93FF"/>
+                      <a:srgbClr val="1F3FD1"/>
                     </a:solidFill>
                   </a:tcPr>
                 </a:tc>
@@ -3580,7 +3580,7 @@
                       <a:noFill/>
                     </a:lnB>
                     <a:solidFill>
-                      <a:srgbClr val="7C93FF"/>
+                      <a:srgbClr val="1F3FD1"/>
                     </a:solidFill>
                   </a:tcPr>
                 </a:tc>
@@ -8871,7 +8871,7 @@
                       <a:noFill/>
                     </a:lnB>
                     <a:solidFill>
-                      <a:srgbClr val="3DD6A0"/>
+                      <a:srgbClr val="0F766E"/>
                     </a:solidFill>
                   </a:tcPr>
                 </a:tc>
@@ -8931,7 +8931,7 @@
                       <a:noFill/>
                     </a:lnB>
                     <a:solidFill>
-                      <a:srgbClr val="3DD6A0"/>
+                      <a:srgbClr val="0F766E"/>
                     </a:solidFill>
                   </a:tcPr>
                 </a:tc>
@@ -9008,7 +9008,7 @@
                       <a:noFill/>
                     </a:lnB>
                     <a:solidFill>
-                      <a:srgbClr val="3DD6A0"/>
+                      <a:srgbClr val="0F766E"/>
                     </a:solidFill>
                   </a:tcPr>
                 </a:tc>

</xml_diff>